<commit_message>
add details about perplexity
</commit_message>
<xml_diff>
--- a/20242-NLP-LLM/lecture notes/Part 1 - Introduction to NLP/1.1-introduction to NLP lecture notes.pptx
+++ b/20242-NLP-LLM/lecture notes/Part 1 - Introduction to NLP/1.1-introduction to NLP lecture notes.pptx
@@ -5,7 +5,7 @@
     <p:sldMasterId id="2147483648" r:id="rId1"/>
   </p:sldMasterIdLst>
   <p:notesMasterIdLst>
-    <p:notesMasterId r:id="rId46"/>
+    <p:notesMasterId r:id="rId48"/>
   </p:notesMasterIdLst>
   <p:sldIdLst>
     <p:sldId id="256" r:id="rId2"/>
@@ -52,6 +52,8 @@
     <p:sldId id="295" r:id="rId43"/>
     <p:sldId id="291" r:id="rId44"/>
     <p:sldId id="290" r:id="rId45"/>
+    <p:sldId id="309" r:id="rId46"/>
+    <p:sldId id="310" r:id="rId47"/>
   </p:sldIdLst>
   <p:sldSz cx="12192000" cy="6858000"/>
   <p:notesSz cx="6858000" cy="9144000"/>
@@ -167,8 +169,7 @@
 <file path=ppt/revisionInfo.xml><?xml version="1.0" encoding="utf-8"?>
 <p1510:revInfo xmlns:a="http://schemas.openxmlformats.org/drawingml/2006/main" xmlns:r="http://schemas.openxmlformats.org/officeDocument/2006/relationships" xmlns:p1510="http://schemas.microsoft.com/office/powerpoint/2015/10/main">
   <p1510:revLst>
-    <p1510:client id="{1430C6B2-0695-4939-9A81-7D403BE3894B}" v="45" dt="2025-04-06T04:26:48.307"/>
-    <p1510:client id="{9DEFE369-4FE8-C0FA-AE89-88E89C96B65F}" v="51" dt="2025-04-07T19:02:15.269"/>
+    <p1510:client id="{743DE9A7-FD69-D988-D276-D6EB926D7F18}" v="73" dt="2025-04-15T04:05:45.740"/>
   </p1510:revLst>
 </p1510:revInfo>
 </file>
@@ -2144,6 +2145,22 @@
     </pc:docChg>
   </pc:docChgLst>
   <pc:docChgLst>
+    <pc:chgData name="Mohammed Fasha" userId="cc64f42d-a1a6-4f08-b97b-0c37f877119f" providerId="ADAL" clId="{5980B3BB-4EB6-4E37-92BF-3A2A8F4B2C7A}"/>
+    <pc:docChg chg="custSel modSld">
+      <pc:chgData name="Mohammed Fasha" userId="cc64f42d-a1a6-4f08-b97b-0c37f877119f" providerId="ADAL" clId="{5980B3BB-4EB6-4E37-92BF-3A2A8F4B2C7A}" dt="2024-10-15T02:28:13.535" v="0" actId="478"/>
+      <pc:docMkLst>
+        <pc:docMk/>
+      </pc:docMkLst>
+      <pc:sldChg chg="delSp mod">
+        <pc:chgData name="Mohammed Fasha" userId="cc64f42d-a1a6-4f08-b97b-0c37f877119f" providerId="ADAL" clId="{5980B3BB-4EB6-4E37-92BF-3A2A8F4B2C7A}" dt="2024-10-15T02:28:13.535" v="0" actId="478"/>
+        <pc:sldMkLst>
+          <pc:docMk/>
+          <pc:sldMk cId="2297456757" sldId="483"/>
+        </pc:sldMkLst>
+      </pc:sldChg>
+    </pc:docChg>
+  </pc:docChgLst>
+  <pc:docChgLst>
     <pc:chgData name="Mohammed Fasha" userId="cc64f42d-a1a6-4f08-b97b-0c37f877119f" providerId="ADAL" clId="{2E5FBF59-3168-4932-9518-582502FE1AD5}"/>
     <pc:docChg chg="undo custSel delSld modSld">
       <pc:chgData name="Mohammed Fasha" userId="cc64f42d-a1a6-4f08-b97b-0c37f877119f" providerId="ADAL" clId="{2E5FBF59-3168-4932-9518-582502FE1AD5}" dt="2024-12-24T08:08:19.987" v="550" actId="20577"/>
@@ -2232,22 +2249,6 @@
         <pc:sldMkLst>
           <pc:docMk/>
           <pc:sldMk cId="32004852" sldId="708"/>
-        </pc:sldMkLst>
-      </pc:sldChg>
-    </pc:docChg>
-  </pc:docChgLst>
-  <pc:docChgLst>
-    <pc:chgData name="Mohammed Fasha" userId="cc64f42d-a1a6-4f08-b97b-0c37f877119f" providerId="ADAL" clId="{5980B3BB-4EB6-4E37-92BF-3A2A8F4B2C7A}"/>
-    <pc:docChg chg="custSel modSld">
-      <pc:chgData name="Mohammed Fasha" userId="cc64f42d-a1a6-4f08-b97b-0c37f877119f" providerId="ADAL" clId="{5980B3BB-4EB6-4E37-92BF-3A2A8F4B2C7A}" dt="2024-10-15T02:28:13.535" v="0" actId="478"/>
-      <pc:docMkLst>
-        <pc:docMk/>
-      </pc:docMkLst>
-      <pc:sldChg chg="delSp mod">
-        <pc:chgData name="Mohammed Fasha" userId="cc64f42d-a1a6-4f08-b97b-0c37f877119f" providerId="ADAL" clId="{5980B3BB-4EB6-4E37-92BF-3A2A8F4B2C7A}" dt="2024-10-15T02:28:13.535" v="0" actId="478"/>
-        <pc:sldMkLst>
-          <pc:docMk/>
-          <pc:sldMk cId="2297456757" sldId="483"/>
         </pc:sldMkLst>
       </pc:sldChg>
     </pc:docChg>
@@ -3151,6 +3152,125 @@
             <pc:docMk/>
             <pc:sldMk cId="2501734364" sldId="308"/>
             <ac:picMk id="11" creationId="{A62FBA81-FB50-9A3F-4551-5D02D03696AD}"/>
+          </ac:picMkLst>
+        </pc:picChg>
+      </pc:sldChg>
+    </pc:docChg>
+  </pc:docChgLst>
+  <pc:docChgLst>
+    <pc:chgData name="Mohammed Fasha" userId="S::mohammed.fasha@uop.edu.jo::cc64f42d-a1a6-4f08-b97b-0c37f877119f" providerId="AD" clId="Web-{743DE9A7-FD69-D988-D276-D6EB926D7F18}"/>
+    <pc:docChg chg="addSld modSld">
+      <pc:chgData name="Mohammed Fasha" userId="S::mohammed.fasha@uop.edu.jo::cc64f42d-a1a6-4f08-b97b-0c37f877119f" providerId="AD" clId="Web-{743DE9A7-FD69-D988-D276-D6EB926D7F18}" dt="2025-04-15T04:05:42.927" v="69" actId="20577"/>
+      <pc:docMkLst>
+        <pc:docMk/>
+      </pc:docMkLst>
+      <pc:sldChg chg="addSp delSp modSp new">
+        <pc:chgData name="Mohammed Fasha" userId="S::mohammed.fasha@uop.edu.jo::cc64f42d-a1a6-4f08-b97b-0c37f877119f" providerId="AD" clId="Web-{743DE9A7-FD69-D988-D276-D6EB926D7F18}" dt="2025-04-15T04:05:33.208" v="66"/>
+        <pc:sldMkLst>
+          <pc:docMk/>
+          <pc:sldMk cId="284403422" sldId="309"/>
+        </pc:sldMkLst>
+        <pc:spChg chg="mod">
+          <ac:chgData name="Mohammed Fasha" userId="S::mohammed.fasha@uop.edu.jo::cc64f42d-a1a6-4f08-b97b-0c37f877119f" providerId="AD" clId="Web-{743DE9A7-FD69-D988-D276-D6EB926D7F18}" dt="2025-04-15T04:05:30.271" v="65" actId="20577"/>
+          <ac:spMkLst>
+            <pc:docMk/>
+            <pc:sldMk cId="284403422" sldId="309"/>
+            <ac:spMk id="2" creationId="{E5CA6D79-3C67-3363-E0F5-5521910B22CB}"/>
+          </ac:spMkLst>
+        </pc:spChg>
+        <pc:spChg chg="add del mod">
+          <ac:chgData name="Mohammed Fasha" userId="S::mohammed.fasha@uop.edu.jo::cc64f42d-a1a6-4f08-b97b-0c37f877119f" providerId="AD" clId="Web-{743DE9A7-FD69-D988-D276-D6EB926D7F18}" dt="2025-04-15T04:03:23.501" v="9"/>
+          <ac:spMkLst>
+            <pc:docMk/>
+            <pc:sldMk cId="284403422" sldId="309"/>
+            <ac:spMk id="3" creationId="{355AFB6F-104A-151E-C5EF-64333CC76435}"/>
+          </ac:spMkLst>
+        </pc:spChg>
+        <pc:spChg chg="add del mod">
+          <ac:chgData name="Mohammed Fasha" userId="S::mohammed.fasha@uop.edu.jo::cc64f42d-a1a6-4f08-b97b-0c37f877119f" providerId="AD" clId="Web-{743DE9A7-FD69-D988-D276-D6EB926D7F18}" dt="2025-04-15T04:04:56.363" v="38"/>
+          <ac:spMkLst>
+            <pc:docMk/>
+            <pc:sldMk cId="284403422" sldId="309"/>
+            <ac:spMk id="8" creationId="{25017C28-A9DC-FE36-B4A7-BAE3FEFBC94C}"/>
+          </ac:spMkLst>
+        </pc:spChg>
+        <pc:spChg chg="add del mod">
+          <ac:chgData name="Mohammed Fasha" userId="S::mohammed.fasha@uop.edu.jo::cc64f42d-a1a6-4f08-b97b-0c37f877119f" providerId="AD" clId="Web-{743DE9A7-FD69-D988-D276-D6EB926D7F18}" dt="2025-04-15T04:05:07.614" v="42"/>
+          <ac:spMkLst>
+            <pc:docMk/>
+            <pc:sldMk cId="284403422" sldId="309"/>
+            <ac:spMk id="11" creationId="{CCDEB9BE-9005-7902-FD4F-A0049B71A35D}"/>
+          </ac:spMkLst>
+        </pc:spChg>
+        <pc:spChg chg="add del mod">
+          <ac:chgData name="Mohammed Fasha" userId="S::mohammed.fasha@uop.edu.jo::cc64f42d-a1a6-4f08-b97b-0c37f877119f" providerId="AD" clId="Web-{743DE9A7-FD69-D988-D276-D6EB926D7F18}" dt="2025-04-15T04:05:33.208" v="66"/>
+          <ac:spMkLst>
+            <pc:docMk/>
+            <pc:sldMk cId="284403422" sldId="309"/>
+            <ac:spMk id="13" creationId="{D2005305-5D30-549D-46DE-B3D23AAAFB73}"/>
+          </ac:spMkLst>
+        </pc:spChg>
+        <pc:picChg chg="add del mod ord">
+          <ac:chgData name="Mohammed Fasha" userId="S::mohammed.fasha@uop.edu.jo::cc64f42d-a1a6-4f08-b97b-0c37f877119f" providerId="AD" clId="Web-{743DE9A7-FD69-D988-D276-D6EB926D7F18}" dt="2025-04-15T04:03:05.656" v="8"/>
+          <ac:picMkLst>
+            <pc:docMk/>
+            <pc:sldMk cId="284403422" sldId="309"/>
+            <ac:picMk id="4" creationId="{9AE292CF-FB16-28F6-9D38-6BE699C6901C}"/>
+          </ac:picMkLst>
+        </pc:picChg>
+        <pc:picChg chg="add del mod ord">
+          <ac:chgData name="Mohammed Fasha" userId="S::mohammed.fasha@uop.edu.jo::cc64f42d-a1a6-4f08-b97b-0c37f877119f" providerId="AD" clId="Web-{743DE9A7-FD69-D988-D276-D6EB926D7F18}" dt="2025-04-15T04:04:15.893" v="23"/>
+          <ac:picMkLst>
+            <pc:docMk/>
+            <pc:sldMk cId="284403422" sldId="309"/>
+            <ac:picMk id="5" creationId="{F2F0E9EA-F2A7-4E6C-A611-D3B22F8DB603}"/>
+          </ac:picMkLst>
+        </pc:picChg>
+        <pc:picChg chg="add del mod">
+          <ac:chgData name="Mohammed Fasha" userId="S::mohammed.fasha@uop.edu.jo::cc64f42d-a1a6-4f08-b97b-0c37f877119f" providerId="AD" clId="Web-{743DE9A7-FD69-D988-D276-D6EB926D7F18}" dt="2025-04-15T04:03:54.658" v="16"/>
+          <ac:picMkLst>
+            <pc:docMk/>
+            <pc:sldMk cId="284403422" sldId="309"/>
+            <ac:picMk id="6" creationId="{09B859C1-1D23-0C0F-9D27-BEBD18A39028}"/>
+          </ac:picMkLst>
+        </pc:picChg>
+        <pc:picChg chg="add mod">
+          <ac:chgData name="Mohammed Fasha" userId="S::mohammed.fasha@uop.edu.jo::cc64f42d-a1a6-4f08-b97b-0c37f877119f" providerId="AD" clId="Web-{743DE9A7-FD69-D988-D276-D6EB926D7F18}" dt="2025-04-15T04:05:11.770" v="47" actId="1076"/>
+          <ac:picMkLst>
+            <pc:docMk/>
+            <pc:sldMk cId="284403422" sldId="309"/>
+            <ac:picMk id="9" creationId="{23D4CC23-AF9C-9389-BF94-A91C5AA33C67}"/>
+          </ac:picMkLst>
+        </pc:picChg>
+      </pc:sldChg>
+      <pc:sldChg chg="addSp delSp modSp new">
+        <pc:chgData name="Mohammed Fasha" userId="S::mohammed.fasha@uop.edu.jo::cc64f42d-a1a6-4f08-b97b-0c37f877119f" providerId="AD" clId="Web-{743DE9A7-FD69-D988-D276-D6EB926D7F18}" dt="2025-04-15T04:05:42.927" v="69" actId="20577"/>
+        <pc:sldMkLst>
+          <pc:docMk/>
+          <pc:sldMk cId="3625093760" sldId="310"/>
+        </pc:sldMkLst>
+        <pc:spChg chg="mod">
+          <ac:chgData name="Mohammed Fasha" userId="S::mohammed.fasha@uop.edu.jo::cc64f42d-a1a6-4f08-b97b-0c37f877119f" providerId="AD" clId="Web-{743DE9A7-FD69-D988-D276-D6EB926D7F18}" dt="2025-04-15T04:05:42.927" v="69" actId="20577"/>
+          <ac:spMkLst>
+            <pc:docMk/>
+            <pc:sldMk cId="3625093760" sldId="310"/>
+            <ac:spMk id="2" creationId="{B0235584-557D-ACA7-77F1-498EAFF042C5}"/>
+          </ac:spMkLst>
+        </pc:spChg>
+        <pc:spChg chg="del">
+          <ac:chgData name="Mohammed Fasha" userId="S::mohammed.fasha@uop.edu.jo::cc64f42d-a1a6-4f08-b97b-0c37f877119f" providerId="AD" clId="Web-{743DE9A7-FD69-D988-D276-D6EB926D7F18}" dt="2025-04-15T04:04:02.518" v="18"/>
+          <ac:spMkLst>
+            <pc:docMk/>
+            <pc:sldMk cId="3625093760" sldId="310"/>
+            <ac:spMk id="3" creationId="{D963FDE0-1CA8-0998-858D-D2FE6E52B8DF}"/>
+          </ac:spMkLst>
+        </pc:spChg>
+        <pc:picChg chg="add mod ord">
+          <ac:chgData name="Mohammed Fasha" userId="S::mohammed.fasha@uop.edu.jo::cc64f42d-a1a6-4f08-b97b-0c37f877119f" providerId="AD" clId="Web-{743DE9A7-FD69-D988-D276-D6EB926D7F18}" dt="2025-04-15T04:04:08.440" v="20" actId="1076"/>
+          <ac:picMkLst>
+            <pc:docMk/>
+            <pc:sldMk cId="3625093760" sldId="310"/>
+            <ac:picMk id="4" creationId="{3778BDC6-93A7-B306-D888-BF7B3767383C}"/>
           </ac:picMkLst>
         </pc:picChg>
       </pc:sldChg>
@@ -6775,7 +6895,7 @@
           <a:p>
             <a:fld id="{13BA03A4-B9F1-404C-8A74-B1AFD6480953}" type="datetimeFigureOut">
               <a:rPr lang="en-US" smtClean="0"/>
-              <a:t>4/7/2025</a:t>
+              <a:t>4/14/2025</a:t>
             </a:fld>
             <a:endParaRPr lang="en-US"/>
           </a:p>
@@ -7189,7 +7309,7 @@
           <a:p>
             <a:fld id="{0DB78E95-DE77-44D3-BDB9-E242948FB112}" type="datetimeFigureOut">
               <a:rPr lang="en-US" smtClean="0"/>
-              <a:t>4/7/2025</a:t>
+              <a:t>4/14/2025</a:t>
             </a:fld>
             <a:endParaRPr lang="en-US"/>
           </a:p>
@@ -7417,7 +7537,7 @@
           <a:p>
             <a:fld id="{0DB78E95-DE77-44D3-BDB9-E242948FB112}" type="datetimeFigureOut">
               <a:rPr lang="en-US" smtClean="0"/>
-              <a:t>4/7/2025</a:t>
+              <a:t>4/14/2025</a:t>
             </a:fld>
             <a:endParaRPr lang="en-US"/>
           </a:p>
@@ -7625,7 +7745,7 @@
           <a:p>
             <a:fld id="{0DB78E95-DE77-44D3-BDB9-E242948FB112}" type="datetimeFigureOut">
               <a:rPr lang="en-US" smtClean="0"/>
-              <a:t>4/7/2025</a:t>
+              <a:t>4/14/2025</a:t>
             </a:fld>
             <a:endParaRPr lang="en-US"/>
           </a:p>
@@ -8352,7 +8472,7 @@
           <a:p>
             <a:fld id="{0DB78E95-DE77-44D3-BDB9-E242948FB112}" type="datetimeFigureOut">
               <a:rPr lang="en-US" smtClean="0"/>
-              <a:t>4/7/2025</a:t>
+              <a:t>4/14/2025</a:t>
             </a:fld>
             <a:endParaRPr lang="en-US"/>
           </a:p>
@@ -8731,7 +8851,7 @@
           <a:p>
             <a:fld id="{0DB78E95-DE77-44D3-BDB9-E242948FB112}" type="datetimeFigureOut">
               <a:rPr lang="en-US" smtClean="0"/>
-              <a:t>4/7/2025</a:t>
+              <a:t>4/14/2025</a:t>
             </a:fld>
             <a:endParaRPr lang="en-US"/>
           </a:p>
@@ -9143,7 +9263,7 @@
           <a:p>
             <a:fld id="{0DB78E95-DE77-44D3-BDB9-E242948FB112}" type="datetimeFigureOut">
               <a:rPr lang="en-US" smtClean="0"/>
-              <a:t>4/7/2025</a:t>
+              <a:t>4/14/2025</a:t>
             </a:fld>
             <a:endParaRPr lang="en-US"/>
           </a:p>
@@ -9284,7 +9404,7 @@
           <a:p>
             <a:fld id="{0DB78E95-DE77-44D3-BDB9-E242948FB112}" type="datetimeFigureOut">
               <a:rPr lang="en-US" smtClean="0"/>
-              <a:t>4/7/2025</a:t>
+              <a:t>4/14/2025</a:t>
             </a:fld>
             <a:endParaRPr lang="en-US"/>
           </a:p>
@@ -9397,7 +9517,7 @@
           <a:p>
             <a:fld id="{0DB78E95-DE77-44D3-BDB9-E242948FB112}" type="datetimeFigureOut">
               <a:rPr lang="en-US" smtClean="0"/>
-              <a:t>4/7/2025</a:t>
+              <a:t>4/14/2025</a:t>
             </a:fld>
             <a:endParaRPr lang="en-US"/>
           </a:p>
@@ -9708,7 +9828,7 @@
           <a:p>
             <a:fld id="{0DB78E95-DE77-44D3-BDB9-E242948FB112}" type="datetimeFigureOut">
               <a:rPr lang="en-US" smtClean="0"/>
-              <a:t>4/7/2025</a:t>
+              <a:t>4/14/2025</a:t>
             </a:fld>
             <a:endParaRPr lang="en-US"/>
           </a:p>
@@ -9996,7 +10116,7 @@
           <a:p>
             <a:fld id="{0DB78E95-DE77-44D3-BDB9-E242948FB112}" type="datetimeFigureOut">
               <a:rPr lang="en-US" smtClean="0"/>
-              <a:t>4/7/2025</a:t>
+              <a:t>4/14/2025</a:t>
             </a:fld>
             <a:endParaRPr lang="en-US"/>
           </a:p>
@@ -10237,7 +10357,7 @@
           <a:p>
             <a:fld id="{0DB78E95-DE77-44D3-BDB9-E242948FB112}" type="datetimeFigureOut">
               <a:rPr lang="en-US" smtClean="0"/>
-              <a:t>4/7/2025</a:t>
+              <a:t>4/14/2025</a:t>
             </a:fld>
             <a:endParaRPr lang="en-US"/>
           </a:p>
@@ -11218,7 +11338,7 @@
               <a:buNone/>
             </a:pPr>
             <a:r>
-              <a:rPr lang="en-US" sz="2800" b="0" u="none" strike="noStrike">
+              <a:rPr lang="en-US" sz="2800" b="0" u="none" strike="noStrike" dirty="0">
                 <a:solidFill>
                   <a:schemeClr val="lt1"/>
                 </a:solidFill>
@@ -11227,7 +11347,7 @@
               </a:rPr>
               <a:t>Tokenize text using NLTK package</a:t>
             </a:r>
-            <a:endParaRPr lang="en-US" sz="2800" b="0" u="none" strike="noStrike">
+            <a:endParaRPr lang="en-US" sz="2800" b="0" u="none" strike="noStrike" dirty="0">
               <a:solidFill>
                 <a:schemeClr val="dk1"/>
               </a:solidFill>
@@ -32682,6 +32802,189 @@
 </p:sld>
 </file>
 
+<file path=ppt/slides/slide45.xml><?xml version="1.0" encoding="utf-8"?>
+<p:sld xmlns:a="http://schemas.openxmlformats.org/drawingml/2006/main" xmlns:r="http://schemas.openxmlformats.org/officeDocument/2006/relationships" xmlns:p="http://schemas.openxmlformats.org/presentationml/2006/main">
+  <p:cSld>
+    <p:spTree>
+      <p:nvGrpSpPr>
+        <p:cNvPr id="1" name=""/>
+        <p:cNvGrpSpPr/>
+        <p:nvPr/>
+      </p:nvGrpSpPr>
+      <p:grpSpPr>
+        <a:xfrm>
+          <a:off x="0" y="0"/>
+          <a:ext cx="0" cy="0"/>
+          <a:chOff x="0" y="0"/>
+          <a:chExt cx="0" cy="0"/>
+        </a:xfrm>
+      </p:grpSpPr>
+      <p:sp>
+        <p:nvSpPr>
+          <p:cNvPr id="2" name="Title 1">
+            <a:extLst>
+              <a:ext uri="{FF2B5EF4-FFF2-40B4-BE49-F238E27FC236}">
+                <a16:creationId xmlns:a16="http://schemas.microsoft.com/office/drawing/2014/main" id="{E5CA6D79-3C67-3363-E0F5-5521910B22CB}"/>
+              </a:ext>
+            </a:extLst>
+          </p:cNvPr>
+          <p:cNvSpPr>
+            <a:spLocks noGrp="1"/>
+          </p:cNvSpPr>
+          <p:nvPr>
+            <p:ph type="title"/>
+          </p:nvPr>
+        </p:nvSpPr>
+        <p:spPr/>
+        <p:txBody>
+          <a:bodyPr/>
+          <a:lstStyle/>
+          <a:p>
+            <a:r>
+              <a:rPr lang="en-US" dirty="0">
+                <a:ea typeface="Calibri Light"/>
+                <a:cs typeface="Calibri Light"/>
+              </a:rPr>
+              <a:t>How Perplexity is Calculated</a:t>
+            </a:r>
+            <a:endParaRPr lang="en-US" dirty="0"/>
+          </a:p>
+        </p:txBody>
+      </p:sp>
+      <p:pic>
+        <p:nvPicPr>
+          <p:cNvPr id="9" name="Picture 8" descr="A math problem with black text&#10;&#10;AI-generated content may be incorrect.">
+            <a:extLst>
+              <a:ext uri="{FF2B5EF4-FFF2-40B4-BE49-F238E27FC236}">
+                <a16:creationId xmlns:a16="http://schemas.microsoft.com/office/drawing/2014/main" id="{23D4CC23-AF9C-9389-BF94-A91C5AA33C67}"/>
+              </a:ext>
+            </a:extLst>
+          </p:cNvPr>
+          <p:cNvPicPr>
+            <a:picLocks noChangeAspect="1"/>
+          </p:cNvPicPr>
+          <p:nvPr/>
+        </p:nvPicPr>
+        <p:blipFill>
+          <a:blip r:embed="rId2"/>
+          <a:stretch>
+            <a:fillRect/>
+          </a:stretch>
+        </p:blipFill>
+        <p:spPr>
+          <a:xfrm>
+            <a:off x="833688" y="1709487"/>
+            <a:ext cx="5391150" cy="2476500"/>
+          </a:xfrm>
+          <a:prstGeom prst="rect">
+            <a:avLst/>
+          </a:prstGeom>
+        </p:spPr>
+      </p:pic>
+    </p:spTree>
+    <p:extLst>
+      <p:ext uri="{BB962C8B-B14F-4D97-AF65-F5344CB8AC3E}">
+        <p14:creationId xmlns:p14="http://schemas.microsoft.com/office/powerpoint/2010/main" val="284403422"/>
+      </p:ext>
+    </p:extLst>
+  </p:cSld>
+  <p:clrMapOvr>
+    <a:masterClrMapping/>
+  </p:clrMapOvr>
+</p:sld>
+</file>
+
+<file path=ppt/slides/slide46.xml><?xml version="1.0" encoding="utf-8"?>
+<p:sld xmlns:a="http://schemas.openxmlformats.org/drawingml/2006/main" xmlns:r="http://schemas.openxmlformats.org/officeDocument/2006/relationships" xmlns:p="http://schemas.openxmlformats.org/presentationml/2006/main">
+  <p:cSld>
+    <p:spTree>
+      <p:nvGrpSpPr>
+        <p:cNvPr id="1" name=""/>
+        <p:cNvGrpSpPr/>
+        <p:nvPr/>
+      </p:nvGrpSpPr>
+      <p:grpSpPr>
+        <a:xfrm>
+          <a:off x="0" y="0"/>
+          <a:ext cx="0" cy="0"/>
+          <a:chOff x="0" y="0"/>
+          <a:chExt cx="0" cy="0"/>
+        </a:xfrm>
+      </p:grpSpPr>
+      <p:sp>
+        <p:nvSpPr>
+          <p:cNvPr id="2" name="Title 1">
+            <a:extLst>
+              <a:ext uri="{FF2B5EF4-FFF2-40B4-BE49-F238E27FC236}">
+                <a16:creationId xmlns:a16="http://schemas.microsoft.com/office/drawing/2014/main" id="{B0235584-557D-ACA7-77F1-498EAFF042C5}"/>
+              </a:ext>
+            </a:extLst>
+          </p:cNvPr>
+          <p:cNvSpPr>
+            <a:spLocks noGrp="1"/>
+          </p:cNvSpPr>
+          <p:nvPr>
+            <p:ph type="title"/>
+          </p:nvPr>
+        </p:nvSpPr>
+        <p:spPr/>
+        <p:txBody>
+          <a:bodyPr/>
+          <a:lstStyle/>
+          <a:p>
+            <a:r>
+              <a:rPr lang="en-US" dirty="0">
+                <a:ea typeface="Calibri Light"/>
+                <a:cs typeface="Calibri Light"/>
+              </a:rPr>
+              <a:t>Quick Example</a:t>
+            </a:r>
+            <a:endParaRPr lang="en-US" dirty="0"/>
+          </a:p>
+        </p:txBody>
+      </p:sp>
+      <p:pic>
+        <p:nvPicPr>
+          <p:cNvPr id="4" name="Content Placeholder 3" descr="A math equations on a white background&#10;&#10;AI-generated content may be incorrect.">
+            <a:extLst>
+              <a:ext uri="{FF2B5EF4-FFF2-40B4-BE49-F238E27FC236}">
+                <a16:creationId xmlns:a16="http://schemas.microsoft.com/office/drawing/2014/main" id="{3778BDC6-93A7-B306-D888-BF7B3767383C}"/>
+              </a:ext>
+            </a:extLst>
+          </p:cNvPr>
+          <p:cNvPicPr>
+            <a:picLocks noGrp="1" noChangeAspect="1"/>
+          </p:cNvPicPr>
+          <p:nvPr>
+            <p:ph/>
+          </p:nvPr>
+        </p:nvPicPr>
+        <p:blipFill>
+          <a:blip r:embed="rId2"/>
+          <a:stretch>
+            <a:fillRect/>
+          </a:stretch>
+        </p:blipFill>
+        <p:spPr>
+          <a:xfrm>
+            <a:off x="837399" y="1850209"/>
+            <a:ext cx="9734550" cy="4000500"/>
+          </a:xfrm>
+        </p:spPr>
+      </p:pic>
+    </p:spTree>
+    <p:extLst>
+      <p:ext uri="{BB962C8B-B14F-4D97-AF65-F5344CB8AC3E}">
+        <p14:creationId xmlns:p14="http://schemas.microsoft.com/office/powerpoint/2010/main" val="3625093760"/>
+      </p:ext>
+    </p:extLst>
+  </p:cSld>
+  <p:clrMapOvr>
+    <a:masterClrMapping/>
+  </p:clrMapOvr>
+</p:sld>
+</file>
+
 <file path=ppt/slides/slide5.xml><?xml version="1.0" encoding="utf-8"?>
 <p:sld xmlns:a="http://schemas.openxmlformats.org/drawingml/2006/main" xmlns:r="http://schemas.openxmlformats.org/officeDocument/2006/relationships" xmlns:p="http://schemas.openxmlformats.org/presentationml/2006/main">
   <p:cSld>

</xml_diff>